<commit_message>
Remove RL circuit and streamlines cases from Sesión 8's recap
Those two Sesión 6 cases were skipped in class, so the "cases already
solved exactly" recap (guión and both deck variants) now lists only the
three that were actually covered: Carbono-14, forense, and paracaidista.
</commit_message>
<xml_diff>
--- a/sesion8/Sesion8_Metodo_de_Euler.pptx
+++ b/sesion8/Sesion8_Metodo_de_Euler.pptx
@@ -5203,7 +5203,7 @@
                 <a:ea typeface="Calibri" pitchFamily="34" charset="-122"/>
                 <a:cs typeface="Calibri" pitchFamily="34" charset="-120"/>
               </a:rPr>
-              <a:t>Sesiones 1–6: Cinco Casos, Cinco Soluciones Exactas</a:t>
+              <a:t>Sesiones 1–6: Tres Casos, Tres Soluciones Exactas</a:t>
             </a:r>
             <a:endParaRPr lang="en-US" sz="2900" dirty="0"/>
           </a:p>
@@ -5218,7 +5218,7 @@
         <p:spPr>
           <a:xfrm>
             <a:off x="548640" y="1600200"/>
-            <a:ext cx="2057949" cy="1554480"/>
+            <a:ext cx="3515258" cy="1554480"/>
           </a:xfrm>
           <a:prstGeom prst="roundRect">
             <a:avLst>
@@ -5239,8 +5239,8 @@
         </p:nvSpPr>
         <p:spPr>
           <a:xfrm>
-            <a:off x="548640" y="1801368"/>
-            <a:ext cx="2057949" cy="640080"/>
+            <a:off x="548640" y="1828800"/>
+            <a:ext cx="3515258" cy="685800"/>
           </a:xfrm>
           <a:prstGeom prst="rect">
             <a:avLst/>
@@ -5256,14 +5256,14 @@
               <a:buNone/>
             </a:pPr>
             <a:r>
-              <a:rPr lang="en-US" sz="3000" dirty="0">
+              <a:rPr lang="en-US" sz="3600" dirty="0">
                 <a:solidFill>
                   <a:srgbClr val="000000"/>
                 </a:solidFill>
               </a:rPr>
               <a:t>🧪</a:t>
             </a:r>
-            <a:endParaRPr lang="en-US" sz="3000" dirty="0"/>
+            <a:endParaRPr lang="en-US" sz="3600" dirty="0"/>
           </a:p>
         </p:txBody>
       </p:sp>
@@ -5275,8 +5275,8 @@
         </p:nvSpPr>
         <p:spPr>
           <a:xfrm>
-            <a:off x="640080" y="2514600"/>
-            <a:ext cx="1875069" cy="548640"/>
+            <a:off x="640080" y="2560320"/>
+            <a:ext cx="3332378" cy="502920"/>
           </a:xfrm>
           <a:prstGeom prst="rect">
             <a:avLst/>
@@ -5295,7 +5295,7 @@
               <a:buNone/>
             </a:pPr>
             <a:r>
-              <a:rPr lang="en-US" sz="1350" b="1" dirty="0">
+              <a:rPr lang="en-US" sz="1600" b="1" dirty="0">
                 <a:solidFill>
                   <a:srgbClr val="F8FAFC"/>
                 </a:solidFill>
@@ -5305,7 +5305,7 @@
               </a:rPr>
               <a:t>Carbono-14</a:t>
             </a:r>
-            <a:endParaRPr lang="en-US" sz="1350" dirty="0"/>
+            <a:endParaRPr lang="en-US" sz="1600" dirty="0"/>
           </a:p>
         </p:txBody>
       </p:sp>
@@ -5317,8 +5317,8 @@
         </p:nvSpPr>
         <p:spPr>
           <a:xfrm>
-            <a:off x="2807757" y="1600200"/>
-            <a:ext cx="2057949" cy="1554480"/>
+            <a:off x="4338218" y="1600200"/>
+            <a:ext cx="3515258" cy="1554480"/>
           </a:xfrm>
           <a:prstGeom prst="roundRect">
             <a:avLst>
@@ -5339,8 +5339,8 @@
         </p:nvSpPr>
         <p:spPr>
           <a:xfrm>
-            <a:off x="2807757" y="1801368"/>
-            <a:ext cx="2057949" cy="640080"/>
+            <a:off x="4338218" y="1828800"/>
+            <a:ext cx="3515258" cy="685800"/>
           </a:xfrm>
           <a:prstGeom prst="rect">
             <a:avLst/>
@@ -5356,14 +5356,14 @@
               <a:buNone/>
             </a:pPr>
             <a:r>
-              <a:rPr lang="en-US" sz="3000" dirty="0">
+              <a:rPr lang="en-US" sz="3600" dirty="0">
                 <a:solidFill>
                   <a:srgbClr val="000000"/>
                 </a:solidFill>
               </a:rPr>
               <a:t>🔬</a:t>
             </a:r>
-            <a:endParaRPr lang="en-US" sz="3000" dirty="0"/>
+            <a:endParaRPr lang="en-US" sz="3600" dirty="0"/>
           </a:p>
         </p:txBody>
       </p:sp>
@@ -5375,8 +5375,8 @@
         </p:nvSpPr>
         <p:spPr>
           <a:xfrm>
-            <a:off x="2899197" y="2514600"/>
-            <a:ext cx="1875069" cy="548640"/>
+            <a:off x="4429658" y="2560320"/>
+            <a:ext cx="3332378" cy="502920"/>
           </a:xfrm>
           <a:prstGeom prst="rect">
             <a:avLst/>
@@ -5395,7 +5395,7 @@
               <a:buNone/>
             </a:pPr>
             <a:r>
-              <a:rPr lang="en-US" sz="1350" b="1" dirty="0">
+              <a:rPr lang="en-US" sz="1600" b="1" dirty="0">
                 <a:solidFill>
                   <a:srgbClr val="F8FAFC"/>
                 </a:solidFill>
@@ -5405,7 +5405,7 @@
               </a:rPr>
               <a:t>Caso forense</a:t>
             </a:r>
-            <a:endParaRPr lang="en-US" sz="1350" dirty="0"/>
+            <a:endParaRPr lang="en-US" sz="1600" dirty="0"/>
           </a:p>
         </p:txBody>
       </p:sp>
@@ -5417,8 +5417,8 @@
         </p:nvSpPr>
         <p:spPr>
           <a:xfrm>
-            <a:off x="5066873" y="1600200"/>
-            <a:ext cx="2057949" cy="1554480"/>
+            <a:off x="8127797" y="1600200"/>
+            <a:ext cx="3515258" cy="1554480"/>
           </a:xfrm>
           <a:prstGeom prst="roundRect">
             <a:avLst>
@@ -5439,8 +5439,8 @@
         </p:nvSpPr>
         <p:spPr>
           <a:xfrm>
-            <a:off x="5066873" y="1801368"/>
-            <a:ext cx="2057949" cy="640080"/>
+            <a:off x="8127797" y="1828800"/>
+            <a:ext cx="3515258" cy="685800"/>
           </a:xfrm>
           <a:prstGeom prst="rect">
             <a:avLst/>
@@ -5456,14 +5456,14 @@
               <a:buNone/>
             </a:pPr>
             <a:r>
-              <a:rPr lang="en-US" sz="3000" dirty="0">
+              <a:rPr lang="en-US" sz="3600" dirty="0">
                 <a:solidFill>
                   <a:srgbClr val="000000"/>
                 </a:solidFill>
               </a:rPr>
-              <a:t>🔌</a:t>
-            </a:r>
-            <a:endParaRPr lang="en-US" sz="3000" dirty="0"/>
+              <a:t>🪂</a:t>
+            </a:r>
+            <a:endParaRPr lang="en-US" sz="3600" dirty="0"/>
           </a:p>
         </p:txBody>
       </p:sp>
@@ -5475,8 +5475,8 @@
         </p:nvSpPr>
         <p:spPr>
           <a:xfrm>
-            <a:off x="5158313" y="2514600"/>
-            <a:ext cx="1875069" cy="548640"/>
+            <a:off x="8219237" y="2560320"/>
+            <a:ext cx="3332378" cy="502920"/>
           </a:xfrm>
           <a:prstGeom prst="rect">
             <a:avLst/>
@@ -5495,7 +5495,7 @@
               <a:buNone/>
             </a:pPr>
             <a:r>
-              <a:rPr lang="en-US" sz="1350" b="1" dirty="0">
+              <a:rPr lang="en-US" sz="1600" b="1" dirty="0">
                 <a:solidFill>
                   <a:srgbClr val="F8FAFC"/>
                 </a:solidFill>
@@ -5503,215 +5503,15 @@
                 <a:ea typeface="Calibri" pitchFamily="34" charset="-122"/>
                 <a:cs typeface="Calibri" pitchFamily="34" charset="-120"/>
               </a:rPr>
-              <a:t>Circuito RL</a:t>
-            </a:r>
-            <a:endParaRPr lang="en-US" sz="1350" dirty="0"/>
+              <a:t>Paracaidista</a:t>
+            </a:r>
+            <a:endParaRPr lang="en-US" sz="1600" dirty="0"/>
           </a:p>
         </p:txBody>
       </p:sp>
       <p:sp>
         <p:nvSpPr>
           <p:cNvPr id="13" name="Shape 11"/>
-          <p:cNvSpPr/>
-          <p:nvPr/>
-        </p:nvSpPr>
-        <p:spPr>
-          <a:xfrm>
-            <a:off x="7325990" y="1600200"/>
-            <a:ext cx="2057949" cy="1554480"/>
-          </a:xfrm>
-          <a:prstGeom prst="roundRect">
-            <a:avLst>
-              <a:gd name="adj" fmla="val 5294"/>
-            </a:avLst>
-          </a:prstGeom>
-          <a:solidFill>
-            <a:srgbClr val="1E293B"/>
-          </a:solidFill>
-          <a:ln/>
-        </p:spPr>
-      </p:sp>
-      <p:sp>
-        <p:nvSpPr>
-          <p:cNvPr id="14" name="Text 12"/>
-          <p:cNvSpPr/>
-          <p:nvPr/>
-        </p:nvSpPr>
-        <p:spPr>
-          <a:xfrm>
-            <a:off x="7325990" y="1801368"/>
-            <a:ext cx="2057949" cy="640080"/>
-          </a:xfrm>
-          <a:prstGeom prst="rect">
-            <a:avLst/>
-          </a:prstGeom>
-          <a:noFill/>
-          <a:ln/>
-        </p:spPr>
-        <p:txBody>
-          <a:bodyPr wrap="square" lIns="0" tIns="0" rIns="0" bIns="0" rtlCol="0" anchor="ctr"/>
-          <a:lstStyle/>
-          <a:p>
-            <a:pPr algn="ctr" indent="0" marL="0">
-              <a:buNone/>
-            </a:pPr>
-            <a:r>
-              <a:rPr lang="en-US" sz="3000" dirty="0">
-                <a:solidFill>
-                  <a:srgbClr val="000000"/>
-                </a:solidFill>
-              </a:rPr>
-              <a:t>🪂</a:t>
-            </a:r>
-            <a:endParaRPr lang="en-US" sz="3000" dirty="0"/>
-          </a:p>
-        </p:txBody>
-      </p:sp>
-      <p:sp>
-        <p:nvSpPr>
-          <p:cNvPr id="15" name="Text 13"/>
-          <p:cNvSpPr/>
-          <p:nvPr/>
-        </p:nvSpPr>
-        <p:spPr>
-          <a:xfrm>
-            <a:off x="7417430" y="2514600"/>
-            <a:ext cx="1875069" cy="548640"/>
-          </a:xfrm>
-          <a:prstGeom prst="rect">
-            <a:avLst/>
-          </a:prstGeom>
-          <a:noFill/>
-          <a:ln/>
-        </p:spPr>
-        <p:txBody>
-          <a:bodyPr wrap="square" lIns="0" tIns="0" rIns="0" bIns="0" rtlCol="0" anchor="t"/>
-          <a:lstStyle/>
-          <a:p>
-            <a:pPr algn="ctr" indent="0" marL="0">
-              <a:lnSpc>
-                <a:spcPct val="105000"/>
-              </a:lnSpc>
-              <a:buNone/>
-            </a:pPr>
-            <a:r>
-              <a:rPr lang="en-US" sz="1350" b="1" dirty="0">
-                <a:solidFill>
-                  <a:srgbClr val="F8FAFC"/>
-                </a:solidFill>
-                <a:latin typeface="Calibri" pitchFamily="34" charset="0"/>
-                <a:ea typeface="Calibri" pitchFamily="34" charset="-122"/>
-                <a:cs typeface="Calibri" pitchFamily="34" charset="-120"/>
-              </a:rPr>
-              <a:t>Paracaidista</a:t>
-            </a:r>
-            <a:endParaRPr lang="en-US" sz="1350" dirty="0"/>
-          </a:p>
-        </p:txBody>
-      </p:sp>
-      <p:sp>
-        <p:nvSpPr>
-          <p:cNvPr id="16" name="Shape 14"/>
-          <p:cNvSpPr/>
-          <p:nvPr/>
-        </p:nvSpPr>
-        <p:spPr>
-          <a:xfrm>
-            <a:off x="9585107" y="1600200"/>
-            <a:ext cx="2057949" cy="1554480"/>
-          </a:xfrm>
-          <a:prstGeom prst="roundRect">
-            <a:avLst>
-              <a:gd name="adj" fmla="val 5294"/>
-            </a:avLst>
-          </a:prstGeom>
-          <a:solidFill>
-            <a:srgbClr val="1E293B"/>
-          </a:solidFill>
-          <a:ln/>
-        </p:spPr>
-      </p:sp>
-      <p:sp>
-        <p:nvSpPr>
-          <p:cNvPr id="17" name="Text 15"/>
-          <p:cNvSpPr/>
-          <p:nvPr/>
-        </p:nvSpPr>
-        <p:spPr>
-          <a:xfrm>
-            <a:off x="9585107" y="1801368"/>
-            <a:ext cx="2057949" cy="640080"/>
-          </a:xfrm>
-          <a:prstGeom prst="rect">
-            <a:avLst/>
-          </a:prstGeom>
-          <a:noFill/>
-          <a:ln/>
-        </p:spPr>
-        <p:txBody>
-          <a:bodyPr wrap="square" lIns="0" tIns="0" rIns="0" bIns="0" rtlCol="0" anchor="ctr"/>
-          <a:lstStyle/>
-          <a:p>
-            <a:pPr algn="ctr" indent="0" marL="0">
-              <a:buNone/>
-            </a:pPr>
-            <a:r>
-              <a:rPr lang="en-US" sz="3000" dirty="0">
-                <a:solidFill>
-                  <a:srgbClr val="000000"/>
-                </a:solidFill>
-              </a:rPr>
-              <a:t>🌊</a:t>
-            </a:r>
-            <a:endParaRPr lang="en-US" sz="3000" dirty="0"/>
-          </a:p>
-        </p:txBody>
-      </p:sp>
-      <p:sp>
-        <p:nvSpPr>
-          <p:cNvPr id="18" name="Text 16"/>
-          <p:cNvSpPr/>
-          <p:nvPr/>
-        </p:nvSpPr>
-        <p:spPr>
-          <a:xfrm>
-            <a:off x="9676547" y="2514600"/>
-            <a:ext cx="1875069" cy="548640"/>
-          </a:xfrm>
-          <a:prstGeom prst="rect">
-            <a:avLst/>
-          </a:prstGeom>
-          <a:noFill/>
-          <a:ln/>
-        </p:spPr>
-        <p:txBody>
-          <a:bodyPr wrap="square" lIns="0" tIns="0" rIns="0" bIns="0" rtlCol="0" anchor="t"/>
-          <a:lstStyle/>
-          <a:p>
-            <a:pPr algn="ctr" indent="0" marL="0">
-              <a:lnSpc>
-                <a:spcPct val="105000"/>
-              </a:lnSpc>
-              <a:buNone/>
-            </a:pPr>
-            <a:r>
-              <a:rPr lang="en-US" sz="1350" b="1" dirty="0">
-                <a:solidFill>
-                  <a:srgbClr val="F8FAFC"/>
-                </a:solidFill>
-                <a:latin typeface="Calibri" pitchFamily="34" charset="0"/>
-                <a:ea typeface="Calibri" pitchFamily="34" charset="-122"/>
-                <a:cs typeface="Calibri" pitchFamily="34" charset="-120"/>
-              </a:rPr>
-              <a:t>Líneas de corriente</a:t>
-            </a:r>
-            <a:endParaRPr lang="en-US" sz="1350" dirty="0"/>
-          </a:p>
-        </p:txBody>
-      </p:sp>
-      <p:sp>
-        <p:nvSpPr>
-          <p:cNvPr id="19" name="Shape 17"/>
           <p:cNvSpPr/>
           <p:nvPr/>
         </p:nvSpPr>
@@ -5738,7 +5538,7 @@
       </p:sp>
       <p:sp>
         <p:nvSpPr>
-          <p:cNvPr id="20" name="Text 18"/>
+          <p:cNvPr id="14" name="Text 12"/>
           <p:cNvSpPr/>
           <p:nvPr/>
         </p:nvSpPr>
@@ -5777,7 +5577,7 @@
       </p:sp>
       <p:sp>
         <p:nvSpPr>
-          <p:cNvPr id="21" name="Text 19"/>
+          <p:cNvPr id="15" name="Text 13"/>
           <p:cNvSpPr/>
           <p:nvPr/>
         </p:nvSpPr>
@@ -5819,7 +5619,7 @@
       </p:sp>
       <p:sp>
         <p:nvSpPr>
-          <p:cNvPr id="22" name="Text 20"/>
+          <p:cNvPr id="16" name="Text 14"/>
           <p:cNvSpPr/>
           <p:nvPr/>
         </p:nvSpPr>
@@ -5858,7 +5658,7 @@
       </p:sp>
       <p:sp>
         <p:nvSpPr>
-          <p:cNvPr id="23" name="Text 21"/>
+          <p:cNvPr id="17" name="Text 15"/>
           <p:cNvSpPr/>
           <p:nvPr/>
         </p:nvSpPr>

</xml_diff>

<commit_message>
Remove team-activity and Tokens-reward framing from Sesión 8
The relay-race team split (Diapositiva 7), the "team of engineers"
aside (Diapositiva 5), and the team discussion + Tokens reward on the
closing exit-ticket (Diapositiva 12) are replaced with individual/
whole-class framing, in both the guión and both deck variants.
</commit_message>
<xml_diff>
--- a/sesion8/Sesion8_Metodo_de_Euler.pptx
+++ b/sesion8/Sesion8_Metodo_de_Euler.pptx
@@ -3964,7 +3964,7 @@
                 <a:ea typeface="Calibri" pitchFamily="34" charset="-122"/>
                 <a:cs typeface="Calibri" pitchFamily="34" charset="-120"/>
               </a:rPr>
-              <a:t>TRABAJO EN EQUIPO · BOLETO DE SALIDA</a:t>
+              <a:t>BOLETO DE SALIDA</a:t>
             </a:r>
             <a:endParaRPr lang="en-US" sz="1300" dirty="0"/>
           </a:p>
@@ -4373,7 +4373,7 @@
                 <a:ea typeface="Calibri" pitchFamily="34" charset="-122"/>
                 <a:cs typeface="Calibri" pitchFamily="34" charset="-120"/>
               </a:rPr>
-              <a:t>🗣️  ¿Por qué tan preciso esta vez, si con el paracaidista el error fue mucho más grande con el mismo número de pasos? Discútanlo en equipo — la respuesta tiene que ver con qué tan curvada es cada función. 🪙 Quien la responda bien se lleva Tokens extra.</a:t>
+              <a:t>🗣️  ¿Por qué tan preciso esta vez, si con el paracaidista el error fue mucho más grande con el mismo número de pasos? Piénsenlo antes de irse — la respuesta tiene que ver con qué tan curvada es cada función. Tráiganla lista para la próxima sesión.</a:t>
             </a:r>
             <a:endParaRPr lang="en-US" sz="1350" dirty="0"/>
           </a:p>
@@ -7708,7 +7708,7 @@
                 <a:ea typeface="Calibri" pitchFamily="34" charset="-122"/>
                 <a:cs typeface="Calibri" pitchFamily="34" charset="-120"/>
               </a:rPr>
-              <a:t>No hay integrales ni sustituciones ingeniosas — solo evaluar f y sumar, una y otra vez. Mecánico y repetitivo: perfecto para una computadora... o un equipo trabajando en cadena.</a:t>
+              <a:t>No hay integrales ni sustituciones ingeniosas — solo evaluar f y sumar, una y otra vez. Mecánico y repetitivo: perfecto para una computadora.</a:t>
             </a:r>
             <a:endParaRPr lang="en-US" sz="1300" dirty="0"/>
           </a:p>
@@ -9404,7 +9404,7 @@
                 <a:ea typeface="Calibri" pitchFamily="34" charset="-122"/>
                 <a:cs typeface="Calibri" pitchFamily="34" charset="-120"/>
               </a:rPr>
-              <a:t>🏃  CARRERA DE RELEVOS</a:t>
+              <a:t>🔗  UNA CADENA DE CÁLCULO</a:t>
             </a:r>
             <a:endParaRPr lang="en-US" sz="1300" dirty="0"/>
           </a:p>
@@ -9446,7 +9446,7 @@
                 <a:ea typeface="Calibri" pitchFamily="34" charset="-122"/>
                 <a:cs typeface="Calibri" pitchFamily="34" charset="-120"/>
               </a:rPr>
-              <a:t>Cada paso solo necesita el resultado del paso anterior. Dividan la sala en 5 equipos — cada uno calcula un paso y se pasa el resultado al siguiente, como una carrera de relevos.</a:t>
+              <a:t>Cada paso solo necesita el resultado del paso anterior — nunca de pasos futuros. Vamos a resolverlo juntos, en el pizarrón, alimentando cada resultado al siguiente paso.</a:t>
             </a:r>
             <a:endParaRPr lang="en-US" sz="1350" dirty="0"/>
           </a:p>
@@ -9488,7 +9488,7 @@
                 <a:ea typeface="Calibri" pitchFamily="34" charset="-122"/>
                 <a:cs typeface="Calibri" pitchFamily="34" charset="-120"/>
               </a:rPr>
-              <a:t>El último equipo entrega la velocidad estimada a los 5 segundos.</a:t>
+              <a:t>Al llegar al quinto paso, tendremos la velocidad estimada a los 5 segundos.</a:t>
             </a:r>
             <a:endParaRPr lang="en-US" sz="1350" dirty="0"/>
           </a:p>

</xml_diff>